<commit_message>
Actualizar README y presentación final
</commit_message>
<xml_diff>
--- a/presentacion_Mabel_Alvarez.pptx
+++ b/presentacion_Mabel_Alvarez.pptx
@@ -3913,7 +3913,7 @@
             </a:r>
             <a:r>
               <a:rPr lang="es-MX" sz="1200" dirty="0"/>
-              <a:t> del objetivo; quedan +0.94 </a:t>
+              <a:t>; los +0.94 </a:t>
             </a:r>
             <a:r>
               <a:rPr lang="es-MX" sz="1200" dirty="0" err="1"/>
@@ -3921,14 +3921,8 @@
             </a:r>
             <a:r>
               <a:rPr lang="es-MX" sz="1200" dirty="0"/>
-              <a:t> por cerrar mediante eficiencia estructural.</a:t>
-            </a:r>
-            <a:endParaRPr sz="1200" b="0" i="1" dirty="0">
-              <a:solidFill>
-                <a:srgbClr val="808081"/>
-              </a:solidFill>
-              <a:latin typeface="Arial"/>
-            </a:endParaRPr>
+              <a:t> restantes requieren eficiencia estructural. </a:t>
+            </a:r>
           </a:p>
         </p:txBody>
       </p:sp>
@@ -4013,7 +4007,7 @@
         <p:spPr>
           <a:xfrm>
             <a:off x="8503920" y="749808"/>
-            <a:ext cx="3063240" cy="1905650"/>
+            <a:ext cx="3063240" cy="1744067"/>
           </a:xfrm>
           <a:prstGeom prst="rect">
             <a:avLst/>
@@ -4042,30 +4036,15 @@
               <a:buChar char="§"/>
             </a:pPr>
             <a:r>
-              <a:rPr lang="es-MX" sz="1050" dirty="0">
-                <a:solidFill>
-                  <a:srgbClr val="4B4A4B"/>
-                </a:solidFill>
-                <a:latin typeface="Arial"/>
-              </a:rPr>
+              <a:rPr lang="es-MX" sz="1050" dirty="0"/>
               <a:t>95% del impacto proviene de </a:t>
             </a:r>
             <a:r>
-              <a:rPr lang="es-MX" sz="1050" dirty="0" err="1">
-                <a:solidFill>
-                  <a:srgbClr val="4B4A4B"/>
-                </a:solidFill>
-                <a:latin typeface="Arial"/>
-              </a:rPr>
+              <a:rPr lang="es-MX" sz="1050" dirty="0" err="1"/>
               <a:t>pricing</a:t>
             </a:r>
             <a:r>
-              <a:rPr lang="es-MX" sz="1050" dirty="0">
-                <a:solidFill>
-                  <a:srgbClr val="4B4A4B"/>
-                </a:solidFill>
-                <a:latin typeface="Arial"/>
-              </a:rPr>
+              <a:rPr lang="es-MX" sz="1050" dirty="0"/>
               <a:t> y recuperación de cuentas.</a:t>
             </a:r>
           </a:p>
@@ -4104,24 +4083,7 @@
             </a:pPr>
             <a:r>
               <a:rPr lang="es-MX" sz="1050" dirty="0"/>
-              <a:t>La mayor oportunidad económica proviene de </a:t>
-            </a:r>
-            <a:r>
-              <a:rPr lang="es-MX" sz="1050" dirty="0" err="1"/>
-              <a:t>pricing</a:t>
-            </a:r>
-            <a:r>
-              <a:rPr lang="es-MX" sz="1050" dirty="0"/>
-              <a:t> selectivo y recuperación de cuentas </a:t>
-            </a:r>
-            <a:r>
-              <a:rPr lang="es-MX" sz="1050" dirty="0">
-                <a:solidFill>
-                  <a:srgbClr val="4B4A4B"/>
-                </a:solidFill>
-                <a:latin typeface="Arial"/>
-              </a:rPr>
-              <a:t>(€617.7 mil).</a:t>
+              <a:t>Las dos principales palancas concentran €1,18 M, equivalentes al 95% del potencial.</a:t>
             </a:r>
           </a:p>
           <a:p>
@@ -4316,7 +4278,7 @@
             </a:r>
             <a:r>
               <a:rPr lang="es-MX" sz="1050" dirty="0"/>
-              <a:t> Implementar un plan de recuperación de cuentas de bajo margen.[Ventas · 2026-09-15] </a:t>
+              <a:t> Implementar un plan de recuperación de cuentas de bajo margen. [Ventas · 2026-09-15] </a:t>
             </a:r>
           </a:p>
           <a:p>
@@ -4493,10 +4455,10 @@
       </p:pic>
       <p:pic>
         <p:nvPicPr>
-          <p:cNvPr id="17" name="Imagen 16">
+          <p:cNvPr id="18" name="Imagen 17">
             <a:extLst>
               <a:ext uri="{FF2B5EF4-FFF2-40B4-BE49-F238E27FC236}">
-                <a16:creationId xmlns:a16="http://schemas.microsoft.com/office/drawing/2014/main" id="{E99A5C6B-A078-5413-CA7C-DEBF66F07D10}"/>
+                <a16:creationId xmlns:a16="http://schemas.microsoft.com/office/drawing/2014/main" id="{5BE4B75C-2FF3-8609-5D73-9B8CE40969CF}"/>
               </a:ext>
             </a:extLst>
           </p:cNvPr>
@@ -4513,20 +4475,116 @@
         </p:blipFill>
         <p:spPr>
           <a:xfrm>
-            <a:off x="530352" y="3025202"/>
-            <a:ext cx="3797738" cy="3241232"/>
+            <a:off x="-18288" y="3054096"/>
+            <a:ext cx="5212358" cy="3048928"/>
           </a:xfrm>
           <a:prstGeom prst="rect">
             <a:avLst/>
           </a:prstGeom>
         </p:spPr>
       </p:pic>
+      <p:sp>
+        <p:nvSpPr>
+          <p:cNvPr id="21" name="TextBox 4">
+            <a:extLst>
+              <a:ext uri="{FF2B5EF4-FFF2-40B4-BE49-F238E27FC236}">
+                <a16:creationId xmlns:a16="http://schemas.microsoft.com/office/drawing/2014/main" id="{F060EF02-3C77-5599-0169-C83287EBAB4E}"/>
+              </a:ext>
+            </a:extLst>
+          </p:cNvPr>
+          <p:cNvSpPr txBox="1"/>
+          <p:nvPr/>
+        </p:nvSpPr>
+        <p:spPr>
+          <a:xfrm>
+            <a:off x="252984" y="6054625"/>
+            <a:ext cx="7635240" cy="276999"/>
+          </a:xfrm>
+          <a:prstGeom prst="rect">
+            <a:avLst/>
+          </a:prstGeom>
+          <a:noFill/>
+          <a:ln>
+            <a:noFill/>
+          </a:ln>
+        </p:spPr>
+        <p:style>
+          <a:lnRef idx="0">
+            <a:scrgbClr r="0" g="0" b="0"/>
+          </a:lnRef>
+          <a:fillRef idx="0">
+            <a:scrgbClr r="0" g="0" b="0"/>
+          </a:fillRef>
+          <a:effectRef idx="0">
+            <a:scrgbClr r="0" g="0" b="0"/>
+          </a:effectRef>
+          <a:fontRef idx="minor">
+            <a:schemeClr val="dk1"/>
+          </a:fontRef>
+        </p:style>
+        <p:txBody>
+          <a:bodyPr wrap="square">
+            <a:spAutoFit/>
+          </a:bodyPr>
+          <a:lstStyle/>
+          <a:p>
+            <a:r>
+              <a:rPr lang="es-MX" sz="1200" b="1" dirty="0">
+                <a:solidFill>
+                  <a:schemeClr val="bg1">
+                    <a:lumMod val="50000"/>
+                  </a:schemeClr>
+                </a:solidFill>
+              </a:rPr>
+              <a:t>Nota:</a:t>
+            </a:r>
+            <a:r>
+              <a:rPr lang="es-MX" sz="1200" dirty="0">
+                <a:solidFill>
+                  <a:schemeClr val="bg1">
+                    <a:lumMod val="50000"/>
+                  </a:schemeClr>
+                </a:solidFill>
+              </a:rPr>
+              <a:t> Escenario de planeación jul-2026–jun-2027. Para H1-2027 se mantiene el run-</a:t>
+            </a:r>
+            <a:r>
+              <a:rPr lang="es-MX" sz="1200" dirty="0" err="1">
+                <a:solidFill>
+                  <a:schemeClr val="bg1">
+                    <a:lumMod val="50000"/>
+                  </a:schemeClr>
+                </a:solidFill>
+              </a:rPr>
+              <a:t>rate</a:t>
+            </a:r>
+            <a:r>
+              <a:rPr lang="es-MX" sz="1200" dirty="0">
+                <a:solidFill>
+                  <a:schemeClr val="bg1">
+                    <a:lumMod val="50000"/>
+                  </a:schemeClr>
+                </a:solidFill>
+              </a:rPr>
+              <a:t> proyectado de H2-2026.</a:t>
+            </a:r>
+            <a:endParaRPr sz="1200" b="0" i="1" dirty="0">
+              <a:solidFill>
+                <a:schemeClr val="bg1">
+                  <a:lumMod val="50000"/>
+                </a:schemeClr>
+              </a:solidFill>
+              <a:latin typeface="Arial"/>
+            </a:endParaRPr>
+          </a:p>
+        </p:txBody>
+      </p:sp>
       <p:pic>
         <p:nvPicPr>
-          <p:cNvPr id="19" name="Imagen 18">
+          <p:cNvPr id="25" name="Imagen 24">
             <a:extLst>
               <a:ext uri="{FF2B5EF4-FFF2-40B4-BE49-F238E27FC236}">
-                <a16:creationId xmlns:a16="http://schemas.microsoft.com/office/drawing/2014/main" id="{791BF3F2-AEC8-BC88-CFF1-2C6F54B40E42}"/>
+                <a16:creationId xmlns:a16="http://schemas.microsoft.com/office/drawing/2014/main" id="{DF24D464-330B-B5C3-36B6-ACCBEF3129F1}"/>
               </a:ext>
             </a:extLst>
           </p:cNvPr>
@@ -4543,8 +4601,8 @@
         </p:blipFill>
         <p:spPr>
           <a:xfrm>
-            <a:off x="4320540" y="3025202"/>
-            <a:ext cx="3939552" cy="3101278"/>
+            <a:off x="4851970" y="3054096"/>
+            <a:ext cx="3487358" cy="2946856"/>
           </a:xfrm>
           <a:prstGeom prst="rect">
             <a:avLst/>
@@ -4585,7 +4643,7 @@
         <p:spPr>
           <a:xfrm>
             <a:off x="502920" y="274320"/>
-            <a:ext cx="11155680" cy="769441"/>
+            <a:ext cx="11155680" cy="430887"/>
           </a:xfrm>
           <a:prstGeom prst="rect">
             <a:avLst/>
@@ -4608,25 +4666,7 @@
                 </a:solidFill>
                 <a:latin typeface="Arial"/>
               </a:rPr>
-              <a:t>Aprobar el plan comercial para capturar +1.06 </a:t>
-            </a:r>
-            <a:r>
-              <a:rPr lang="es-MX" sz="2200" b="1" dirty="0" err="1">
-                <a:solidFill>
-                  <a:srgbClr val="002D6F"/>
-                </a:solidFill>
-                <a:latin typeface="Arial"/>
-              </a:rPr>
-              <a:t>pp</a:t>
-            </a:r>
-            <a:r>
-              <a:rPr lang="es-MX" sz="2200" b="1" dirty="0">
-                <a:solidFill>
-                  <a:srgbClr val="002D6F"/>
-                </a:solidFill>
-                <a:latin typeface="Arial"/>
-              </a:rPr>
-              <a:t> y lanzar iniciativas de eficiencia para cerrar los +0.94 </a:t>
+              <a:t>Aprobar el plan comercial y lanzar eficiencias para cerrar los +0,94 </a:t>
             </a:r>
             <a:r>
               <a:rPr lang="es-MX" sz="2200" b="1" dirty="0" err="1">
@@ -4663,8 +4703,8 @@
         </p:nvSpPr>
         <p:spPr>
           <a:xfrm>
-            <a:off x="502920" y="1097280"/>
-            <a:ext cx="5111496" cy="3231654"/>
+            <a:off x="533400" y="1097280"/>
+            <a:ext cx="5081016" cy="3600986"/>
           </a:xfrm>
           <a:prstGeom prst="rect">
             <a:avLst/>
@@ -4690,52 +4730,80 @@
             </a:r>
           </a:p>
           <a:p>
+            <a:pPr marL="171450" lvl="0" indent="-171450">
+              <a:buFont typeface="Arial" panose="020B0604020202020204" pitchFamily="34" charset="0"/>
+              <a:buChar char="•"/>
+            </a:pPr>
+            <a:r>
+              <a:rPr lang="es-MX" sz="1200" dirty="0"/>
+              <a:t>Implementar </a:t>
+            </a:r>
+            <a:r>
+              <a:rPr lang="es-MX" sz="1200" dirty="0" err="1"/>
+              <a:t>pricing</a:t>
+            </a:r>
+            <a:r>
+              <a:rPr lang="es-MX" sz="1200" dirty="0"/>
+              <a:t> selectivo. </a:t>
+            </a:r>
+          </a:p>
+          <a:p>
+            <a:pPr marL="171450" lvl="0" indent="-171450">
+              <a:buFont typeface="Arial" panose="020B0604020202020204" pitchFamily="34" charset="0"/>
+              <a:buChar char="•"/>
+            </a:pPr>
+            <a:r>
+              <a:rPr lang="es-MX" sz="1200" dirty="0"/>
+              <a:t>Recuperar cuentas de bajo margen. </a:t>
+            </a:r>
+          </a:p>
+          <a:p>
+            <a:pPr marL="171450" lvl="0" indent="-171450">
+              <a:buFont typeface="Arial" panose="020B0604020202020204" pitchFamily="34" charset="0"/>
+              <a:buChar char="•"/>
+            </a:pPr>
+            <a:r>
+              <a:rPr lang="es-MX" sz="1200" dirty="0"/>
+              <a:t>Reducir las causas de notas de crédito.</a:t>
+            </a:r>
+          </a:p>
+          <a:p>
             <a:pPr lvl="0"/>
-            <a:r>
-              <a:rPr lang="es-MX" sz="1200" dirty="0" err="1"/>
-              <a:t>Pricing</a:t>
-            </a:r>
-            <a:r>
-              <a:rPr lang="es-MX" sz="1200" dirty="0"/>
-              <a:t> selectivo </a:t>
-            </a:r>
+            <a:endParaRPr lang="es-MX" sz="1200" b="1" dirty="0"/>
           </a:p>
           <a:p>
             <a:pPr lvl="0"/>
-            <a:r>
-              <a:rPr lang="es-MX" sz="1200" dirty="0"/>
-              <a:t>Recuperación de cuentas de bajo margen </a:t>
-            </a:r>
-          </a:p>
-          <a:p>
-            <a:pPr lvl="0"/>
-            <a:r>
-              <a:rPr lang="es-MX" sz="1200" dirty="0"/>
-              <a:t>Reducir notas de crédito </a:t>
-            </a:r>
-          </a:p>
-          <a:p>
             <a:r>
               <a:rPr lang="es-MX" sz="1200" b="1" dirty="0"/>
               <a:t>3–6 meses</a:t>
             </a:r>
           </a:p>
           <a:p>
-            <a:pPr lvl="0"/>
+            <a:pPr marL="171450" lvl="0" indent="-171450">
+              <a:buFont typeface="Arial" panose="020B0604020202020204" pitchFamily="34" charset="0"/>
+              <a:buChar char="•"/>
+            </a:pPr>
+            <a:r>
+              <a:rPr lang="es-MX" sz="1200" dirty="0"/>
+              <a:t>Monitorear </a:t>
+            </a:r>
             <a:r>
               <a:rPr lang="es-MX" sz="1200" dirty="0" err="1"/>
               <a:t>Customer</a:t>
             </a:r>
             <a:r>
               <a:rPr lang="es-MX" sz="1200" dirty="0"/>
-              <a:t> Health mensual </a:t>
-            </a:r>
-          </a:p>
-          <a:p>
-            <a:pPr lvl="0"/>
+              <a:t> Health mensualmente. </a:t>
+            </a:r>
+          </a:p>
+          <a:p>
+            <a:pPr marL="171450" lvl="0" indent="-171450">
+              <a:buFont typeface="Arial" panose="020B0604020202020204" pitchFamily="34" charset="0"/>
+              <a:buChar char="•"/>
+            </a:pPr>
             <a:r>
               <a:rPr lang="es-MX" sz="1200" dirty="0"/>
-              <a:t>Optimizar </a:t>
+              <a:t>Optimizar el </a:t>
             </a:r>
             <a:r>
               <a:rPr lang="es-MX" sz="1200" dirty="0" err="1"/>
@@ -4743,15 +4811,25 @@
             </a:r>
             <a:r>
               <a:rPr lang="es-MX" sz="1200" dirty="0"/>
-              <a:t> </a:t>
-            </a:r>
-          </a:p>
-          <a:p>
-            <a:pPr lvl="0"/>
+              <a:t> de productos. </a:t>
+            </a:r>
+          </a:p>
+          <a:p>
+            <a:pPr marL="171450" lvl="0" indent="-171450">
+              <a:buFont typeface="Arial" panose="020B0604020202020204" pitchFamily="34" charset="0"/>
+              <a:buChar char="•"/>
+            </a:pPr>
             <a:r>
               <a:rPr lang="es-MX" sz="1200" dirty="0"/>
-              <a:t>Medir impacto real </a:t>
-            </a:r>
+              <a:t>Medir el impacto real sobre el margen.</a:t>
+            </a:r>
+          </a:p>
+          <a:p>
+            <a:pPr marL="171450" lvl="0" indent="-171450">
+              <a:buFont typeface="Arial" panose="020B0604020202020204" pitchFamily="34" charset="0"/>
+              <a:buChar char="•"/>
+            </a:pPr>
+            <a:endParaRPr lang="es-MX" sz="1200" dirty="0"/>
           </a:p>
           <a:p>
             <a:r>
@@ -4760,34 +4838,42 @@
             </a:r>
           </a:p>
           <a:p>
-            <a:pPr lvl="0"/>
+            <a:pPr marL="171450" lvl="0" indent="-171450">
+              <a:buFont typeface="Arial" panose="020B0604020202020204" pitchFamily="34" charset="0"/>
+              <a:buChar char="•"/>
+            </a:pPr>
             <a:r>
               <a:rPr lang="es-MX" sz="1200" dirty="0"/>
-              <a:t>Compras y eficiencia operativa </a:t>
-            </a:r>
-          </a:p>
-          <a:p>
-            <a:pPr lvl="0"/>
+              <a:t>Integrar compras y eficiencia operativa. </a:t>
+            </a:r>
+          </a:p>
+          <a:p>
+            <a:pPr marL="171450" lvl="0" indent="-171450">
+              <a:buFont typeface="Arial" panose="020B0604020202020204" pitchFamily="34" charset="0"/>
+              <a:buChar char="•"/>
+            </a:pPr>
+            <a:r>
+              <a:rPr lang="es-MX" sz="1200" dirty="0"/>
+              <a:t>Actualizar el </a:t>
+            </a:r>
             <a:r>
               <a:rPr lang="es-MX" sz="1200" dirty="0" err="1"/>
-              <a:t>Forecast</a:t>
+              <a:t>forecast</a:t>
             </a:r>
             <a:r>
               <a:rPr lang="es-MX" sz="1200" dirty="0"/>
-              <a:t> mensual </a:t>
-            </a:r>
-          </a:p>
-          <a:p>
-            <a:pPr lvl="0"/>
+              <a:t> mensualmente. </a:t>
+            </a:r>
+          </a:p>
+          <a:p>
+            <a:pPr marL="171450" lvl="0" indent="-171450">
+              <a:buFont typeface="Arial" panose="020B0604020202020204" pitchFamily="34" charset="0"/>
+              <a:buChar char="•"/>
+            </a:pPr>
             <a:r>
               <a:rPr lang="es-MX" sz="1200" dirty="0"/>
-              <a:t>Cerrar el gap restante de +0.94 </a:t>
-            </a:r>
-            <a:r>
-              <a:rPr lang="es-MX" sz="1200" dirty="0" err="1"/>
-              <a:t>pp</a:t>
-            </a:r>
-            <a:endParaRPr lang="es-MX" sz="1200" dirty="0"/>
+              <a:t>Cerrar la brecha restante de +0,94 pp.</a:t>
+            </a:r>
           </a:p>
           <a:p>
             <a:pPr lvl="0"/>
@@ -4968,10 +5054,10 @@
       </p:pic>
       <p:pic>
         <p:nvPicPr>
-          <p:cNvPr id="11" name="Imagen 10">
+          <p:cNvPr id="9" name="Imagen 8">
             <a:extLst>
               <a:ext uri="{FF2B5EF4-FFF2-40B4-BE49-F238E27FC236}">
-                <a16:creationId xmlns:a16="http://schemas.microsoft.com/office/drawing/2014/main" id="{81B24E08-DF64-2625-8CE8-8E743C9101DC}"/>
+                <a16:creationId xmlns:a16="http://schemas.microsoft.com/office/drawing/2014/main" id="{56FF5F60-3470-6AF2-65F3-2EA4B315A0F6}"/>
               </a:ext>
             </a:extLst>
           </p:cNvPr>
@@ -4988,14 +5074,57 @@
         </p:blipFill>
         <p:spPr>
           <a:xfrm>
-            <a:off x="5989320" y="1907105"/>
-            <a:ext cx="5864352" cy="3590880"/>
+            <a:off x="5507497" y="1097280"/>
+            <a:ext cx="6388847" cy="3600986"/>
           </a:xfrm>
           <a:prstGeom prst="rect">
             <a:avLst/>
           </a:prstGeom>
         </p:spPr>
       </p:pic>
+      <p:sp>
+        <p:nvSpPr>
+          <p:cNvPr id="12" name="TextBox 2">
+            <a:extLst>
+              <a:ext uri="{FF2B5EF4-FFF2-40B4-BE49-F238E27FC236}">
+                <a16:creationId xmlns:a16="http://schemas.microsoft.com/office/drawing/2014/main" id="{05414BE1-DF20-CDB3-BD04-06F02216D4D6}"/>
+              </a:ext>
+            </a:extLst>
+          </p:cNvPr>
+          <p:cNvSpPr txBox="1"/>
+          <p:nvPr/>
+        </p:nvSpPr>
+        <p:spPr>
+          <a:xfrm>
+            <a:off x="533400" y="5465064"/>
+            <a:ext cx="5081016" cy="461665"/>
+          </a:xfrm>
+          <a:prstGeom prst="rect">
+            <a:avLst/>
+          </a:prstGeom>
+          <a:solidFill>
+            <a:srgbClr val="FFFFFF"/>
+          </a:solidFill>
+          <a:ln w="12700">
+            <a:solidFill>
+              <a:srgbClr val="E8ECF1"/>
+            </a:solidFill>
+          </a:ln>
+        </p:spPr>
+        <p:txBody>
+          <a:bodyPr wrap="square">
+            <a:spAutoFit/>
+          </a:bodyPr>
+          <a:lstStyle/>
+          <a:p>
+            <a:r>
+              <a:rPr lang="es-MX" sz="1200" b="1" dirty="0"/>
+              <a:t>Base de planeación 12 meses: €117,05 M. Potencial comercial identificado: €1,24 M.</a:t>
+            </a:r>
+            <a:endParaRPr lang="es-MX" sz="1200" dirty="0"/>
+          </a:p>
+        </p:txBody>
+      </p:sp>
     </p:spTree>
   </p:cSld>
   <p:clrMapOvr>

</xml_diff>